<commit_message>
Calgary Transit demo: cut to a 13-minute talk with a focused dashboard
The deck drops from 16 slides to 11 with one idea per slide and a 4-minute demo
script in the notes. The dashboard keeps one headline, three tiles and two charts
(recovery, and the Lost Property catch). The approach page becomes six short steps.

Co-Authored-By: Claude Opus 5.5 <noreply@anthropic.com>
</commit_message>
<xml_diff>
--- a/demos/calgary-transit/web/public/downloads/prime-case-study.pptx
+++ b/demos/calgary-transit/web/public/downloads/prime-case-study.pptx
@@ -16,14 +16,9 @@
     <p:sldId id="264" r:id="rId10"/>
     <p:sldId id="265" r:id="rId11"/>
     <p:sldId id="266" r:id="rId12"/>
-    <p:sldId id="267" r:id="rId13"/>
-    <p:sldId id="268" r:id="rId14"/>
-    <p:sldId id="269" r:id="rId15"/>
-    <p:sldId id="270" r:id="rId16"/>
-    <p:sldId id="271" r:id="rId17"/>
   </p:sldIdLst>
   <p:notesMasterIdLst>
-    <p:notesMasterId r:id="rId18"/>
+    <p:notesMasterId r:id="rId13"/>
   </p:notesMasterIdLst>
   <p:sldSz cx="9144000" cy="5143500"/>
   <p:notesSz cx="5143500" cy="9144000"/>
@@ -517,8 +512,7 @@
           <a:p>
             <a:r>
               <a:rPr lang="en-US" dirty="0"/>
-              <a:t>• Thank the panel. One line on who you are: [Your story: one sentence on your background].
-• Frame: a data product I led end to end, then the same process on the City's own open data, live.</a:t>
+              <a:t>• [Your story: one line on who you are.] Then: 'I'll walk through PRIME, then show you the same approach working on the City's data.'</a:t>
             </a:r>
             <a:endParaRPr lang="en-US" dirty="0"/>
           </a:p>
@@ -606,7 +600,7 @@
           <a:p>
             <a:r>
               <a:rPr lang="en-US" dirty="0"/>
-              <a:t>• Say it plainly: I can't show client data, so here is the same process on data you know.</a:t>
+              <a:t>• Land the closing line slowly. It's the bridge to the role.</a:t>
             </a:r>
             <a:endParaRPr lang="en-US" dirty="0"/>
           </a:p>
@@ -694,8 +688,7 @@
           <a:p>
             <a:r>
               <a:rPr lang="en-US" dirty="0"/>
-              <a:t>• The users here are my assumption of who'd use this at the City; in a real engagement I'd confirm them in short interviews.
-• The full version of this is the Approach page on the site.</a:t>
+              <a:t>• Stop talking. Leave this up for questions.</a:t>
             </a:r>
             <a:endParaRPr lang="en-US" dirty="0"/>
           </a:p>
@@ -719,450 +712,6 @@
             <a:fld id="{F7021451-1387-4CA6-816F-3879F97B5CBC}" type="slidenum">
               <a:rPr lang="en-US"/>
               <a:t>11</a:t>
-            </a:fld>
-            <a:endParaRPr lang="en-US"/>
-          </a:p>
-        </p:txBody>
-      </p:sp>
-    </p:spTree>
-    <p:extLst>
-      <p:ext uri="{BB962C8B-B14F-4D97-AF65-F5344CB8AC3E}">
-        <p14:creationId xmlns:p14="http://schemas.microsoft.com/office/powerpoint/2010/main" val="1024086991"/>
-      </p:ext>
-    </p:extLst>
-  </p:cSld>
-  <p:clrMapOvr>
-    <a:masterClrMapping/>
-  </p:clrMapOvr>
-</p:notes>
-</file>
-
-<file path=ppt/notesSlides/notesSlide12.xml><?xml version="1.0" encoding="utf-8"?>
-<p:notes xmlns:a="http://schemas.openxmlformats.org/drawingml/2006/main" xmlns:r="http://schemas.openxmlformats.org/officeDocument/2006/relationships" xmlns:p="http://schemas.openxmlformats.org/presentationml/2006/main">
-  <p:cSld>
-    <p:spTree>
-      <p:nvGrpSpPr>
-        <p:cNvPr id="1" name=""/>
-        <p:cNvGrpSpPr/>
-        <p:nvPr/>
-      </p:nvGrpSpPr>
-      <p:grpSpPr>
-        <a:xfrm>
-          <a:off x="0" y="0"/>
-          <a:ext cx="0" cy="0"/>
-          <a:chOff x="0" y="0"/>
-          <a:chExt cx="0" cy="0"/>
-        </a:xfrm>
-      </p:grpSpPr>
-      <p:sp>
-        <p:nvSpPr>
-          <p:cNvPr id="2" name="Slide Image Placeholder 1"/>
-          <p:cNvSpPr>
-            <a:spLocks noGrp="1" noRot="1" noChangeAspect="1"/>
-          </p:cNvSpPr>
-          <p:nvPr>
-            <p:ph type="sldImg"/>
-          </p:nvPr>
-        </p:nvSpPr>
-        <p:spPr/>
-      </p:sp>
-      <p:sp>
-        <p:nvSpPr>
-          <p:cNvPr id="3" name="Notes Placeholder 2"/>
-          <p:cNvSpPr>
-            <a:spLocks noGrp="1"/>
-          </p:cNvSpPr>
-          <p:nvPr>
-            <p:ph type="body" idx="1"/>
-          </p:nvPr>
-        </p:nvSpPr>
-        <p:spPr/>
-        <p:txBody>
-          <a:bodyPr/>
-          <a:lstStyle/>
-          <a:p>
-            <a:r>
-              <a:rPr lang="en-US" dirty="0"/>
-              <a:t>• LIVE DEMO (about 90 seconds): switch to the Dashboard. Read the headline: riders back to 95% of 2019 on 99% of the service, feedback per trip up 12%. Then the 'what riders contact 311 about' chart: fares and passes, stops and stations.
-• If the room has no internet, the slides still carry the story.</a:t>
-            </a:r>
-            <a:endParaRPr lang="en-US" dirty="0"/>
-          </a:p>
-        </p:txBody>
-      </p:sp>
-      <p:sp>
-        <p:nvSpPr>
-          <p:cNvPr id="4" name="Slide Number Placeholder 3"/>
-          <p:cNvSpPr>
-            <a:spLocks noGrp="1"/>
-          </p:cNvSpPr>
-          <p:nvPr>
-            <p:ph type="sldNum" sz="quarter" idx="10"/>
-          </p:nvPr>
-        </p:nvSpPr>
-        <p:spPr/>
-        <p:txBody>
-          <a:bodyPr/>
-          <a:lstStyle/>
-          <a:p>
-            <a:fld id="{F7021451-1387-4CA6-816F-3879F97B5CBC}" type="slidenum">
-              <a:rPr lang="en-US"/>
-              <a:t>12</a:t>
-            </a:fld>
-            <a:endParaRPr lang="en-US"/>
-          </a:p>
-        </p:txBody>
-      </p:sp>
-    </p:spTree>
-    <p:extLst>
-      <p:ext uri="{BB962C8B-B14F-4D97-AF65-F5344CB8AC3E}">
-        <p14:creationId xmlns:p14="http://schemas.microsoft.com/office/powerpoint/2010/main" val="1024086991"/>
-      </p:ext>
-    </p:extLst>
-  </p:cSld>
-  <p:clrMapOvr>
-    <a:masterClrMapping/>
-  </p:clrMapOvr>
-</p:notes>
-</file>
-
-<file path=ppt/notesSlides/notesSlide13.xml><?xml version="1.0" encoding="utf-8"?>
-<p:notes xmlns:a="http://schemas.openxmlformats.org/drawingml/2006/main" xmlns:r="http://schemas.openxmlformats.org/officeDocument/2006/relationships" xmlns:p="http://schemas.openxmlformats.org/presentationml/2006/main">
-  <p:cSld>
-    <p:spTree>
-      <p:nvGrpSpPr>
-        <p:cNvPr id="1" name=""/>
-        <p:cNvGrpSpPr/>
-        <p:nvPr/>
-      </p:nvGrpSpPr>
-      <p:grpSpPr>
-        <a:xfrm>
-          <a:off x="0" y="0"/>
-          <a:ext cx="0" cy="0"/>
-          <a:chOff x="0" y="0"/>
-          <a:chExt cx="0" cy="0"/>
-        </a:xfrm>
-      </p:grpSpPr>
-      <p:sp>
-        <p:nvSpPr>
-          <p:cNvPr id="2" name="Slide Image Placeholder 1"/>
-          <p:cNvSpPr>
-            <a:spLocks noGrp="1" noRot="1" noChangeAspect="1"/>
-          </p:cNvSpPr>
-          <p:nvPr>
-            <p:ph type="sldImg"/>
-          </p:nvPr>
-        </p:nvSpPr>
-        <p:spPr/>
-      </p:sp>
-      <p:sp>
-        <p:nvSpPr>
-          <p:cNvPr id="3" name="Notes Placeholder 2"/>
-          <p:cNvSpPr>
-            <a:spLocks noGrp="1"/>
-          </p:cNvSpPr>
-          <p:nvPr>
-            <p:ph type="body" idx="1"/>
-          </p:nvPr>
-        </p:nvSpPr>
-        <p:spPr/>
-        <p:txBody>
-          <a:bodyPr/>
-          <a:lstStyle/>
-          <a:p>
-            <a:r>
-              <a:rPr lang="en-US" dirty="0"/>
-              <a:t>• [Your story: the stakeholder conversation that got the data contract agreed. Who pushed back, and what changed their mind?]
-• The Lost Property catch is the best analytical example: a second look at a number that seemed too dramatic, then a governed fix so nobody repeats the mistake, including the AI.</a:t>
-            </a:r>
-            <a:endParaRPr lang="en-US" dirty="0"/>
-          </a:p>
-        </p:txBody>
-      </p:sp>
-      <p:sp>
-        <p:nvSpPr>
-          <p:cNvPr id="4" name="Slide Number Placeholder 3"/>
-          <p:cNvSpPr>
-            <a:spLocks noGrp="1"/>
-          </p:cNvSpPr>
-          <p:nvPr>
-            <p:ph type="sldNum" sz="quarter" idx="10"/>
-          </p:nvPr>
-        </p:nvSpPr>
-        <p:spPr/>
-        <p:txBody>
-          <a:bodyPr/>
-          <a:lstStyle/>
-          <a:p>
-            <a:fld id="{F7021451-1387-4CA6-816F-3879F97B5CBC}" type="slidenum">
-              <a:rPr lang="en-US"/>
-              <a:t>13</a:t>
-            </a:fld>
-            <a:endParaRPr lang="en-US"/>
-          </a:p>
-        </p:txBody>
-      </p:sp>
-    </p:spTree>
-    <p:extLst>
-      <p:ext uri="{BB962C8B-B14F-4D97-AF65-F5344CB8AC3E}">
-        <p14:creationId xmlns:p14="http://schemas.microsoft.com/office/powerpoint/2010/main" val="1024086991"/>
-      </p:ext>
-    </p:extLst>
-  </p:cSld>
-  <p:clrMapOvr>
-    <a:masterClrMapping/>
-  </p:clrMapOvr>
-</p:notes>
-</file>
-
-<file path=ppt/notesSlides/notesSlide14.xml><?xml version="1.0" encoding="utf-8"?>
-<p:notes xmlns:a="http://schemas.openxmlformats.org/drawingml/2006/main" xmlns:r="http://schemas.openxmlformats.org/officeDocument/2006/relationships" xmlns:p="http://schemas.openxmlformats.org/presentationml/2006/main">
-  <p:cSld>
-    <p:spTree>
-      <p:nvGrpSpPr>
-        <p:cNvPr id="1" name=""/>
-        <p:cNvGrpSpPr/>
-        <p:nvPr/>
-      </p:nvGrpSpPr>
-      <p:grpSpPr>
-        <a:xfrm>
-          <a:off x="0" y="0"/>
-          <a:ext cx="0" cy="0"/>
-          <a:chOff x="0" y="0"/>
-          <a:chExt cx="0" cy="0"/>
-        </a:xfrm>
-      </p:grpSpPr>
-      <p:sp>
-        <p:nvSpPr>
-          <p:cNvPr id="2" name="Slide Image Placeholder 1"/>
-          <p:cNvSpPr>
-            <a:spLocks noGrp="1" noRot="1" noChangeAspect="1"/>
-          </p:cNvSpPr>
-          <p:nvPr>
-            <p:ph type="sldImg"/>
-          </p:nvPr>
-        </p:nvSpPr>
-        <p:spPr/>
-      </p:sp>
-      <p:sp>
-        <p:nvSpPr>
-          <p:cNvPr id="3" name="Notes Placeholder 2"/>
-          <p:cNvSpPr>
-            <a:spLocks noGrp="1"/>
-          </p:cNvSpPr>
-          <p:nvPr>
-            <p:ph type="body" idx="1"/>
-          </p:nvPr>
-        </p:nvSpPr>
-        <p:spPr/>
-        <p:txBody>
-          <a:bodyPr/>
-          <a:lstStyle/>
-          <a:p>
-            <a:r>
-              <a:rPr lang="en-US" dirty="0"/>
-              <a:t>• LIVE DEMO (about 60 seconds): open Ask the data and click 'How has ridership recovered since the pandemic?'. Show the SQL, then point at the same number on the dashboard.
-• Why it's the proudest part: it's where governance stops being overhead and becomes the reason people can self-serve.</a:t>
-            </a:r>
-            <a:endParaRPr lang="en-US" dirty="0"/>
-          </a:p>
-        </p:txBody>
-      </p:sp>
-      <p:sp>
-        <p:nvSpPr>
-          <p:cNvPr id="4" name="Slide Number Placeholder 3"/>
-          <p:cNvSpPr>
-            <a:spLocks noGrp="1"/>
-          </p:cNvSpPr>
-          <p:nvPr>
-            <p:ph type="sldNum" sz="quarter" idx="10"/>
-          </p:nvPr>
-        </p:nvSpPr>
-        <p:spPr/>
-        <p:txBody>
-          <a:bodyPr/>
-          <a:lstStyle/>
-          <a:p>
-            <a:fld id="{F7021451-1387-4CA6-816F-3879F97B5CBC}" type="slidenum">
-              <a:rPr lang="en-US"/>
-              <a:t>14</a:t>
-            </a:fld>
-            <a:endParaRPr lang="en-US"/>
-          </a:p>
-        </p:txBody>
-      </p:sp>
-    </p:spTree>
-    <p:extLst>
-      <p:ext uri="{BB962C8B-B14F-4D97-AF65-F5344CB8AC3E}">
-        <p14:creationId xmlns:p14="http://schemas.microsoft.com/office/powerpoint/2010/main" val="1024086991"/>
-      </p:ext>
-    </p:extLst>
-  </p:cSld>
-  <p:clrMapOvr>
-    <a:masterClrMapping/>
-  </p:clrMapOvr>
-</p:notes>
-</file>
-
-<file path=ppt/notesSlides/notesSlide15.xml><?xml version="1.0" encoding="utf-8"?>
-<p:notes xmlns:a="http://schemas.openxmlformats.org/drawingml/2006/main" xmlns:r="http://schemas.openxmlformats.org/officeDocument/2006/relationships" xmlns:p="http://schemas.openxmlformats.org/presentationml/2006/main">
-  <p:cSld>
-    <p:spTree>
-      <p:nvGrpSpPr>
-        <p:cNvPr id="1" name=""/>
-        <p:cNvGrpSpPr/>
-        <p:nvPr/>
-      </p:nvGrpSpPr>
-      <p:grpSpPr>
-        <a:xfrm>
-          <a:off x="0" y="0"/>
-          <a:ext cx="0" cy="0"/>
-          <a:chOff x="0" y="0"/>
-          <a:chExt cx="0" cy="0"/>
-        </a:xfrm>
-      </p:grpSpPr>
-      <p:sp>
-        <p:nvSpPr>
-          <p:cNvPr id="2" name="Slide Image Placeholder 1"/>
-          <p:cNvSpPr>
-            <a:spLocks noGrp="1" noRot="1" noChangeAspect="1"/>
-          </p:cNvSpPr>
-          <p:nvPr>
-            <p:ph type="sldImg"/>
-          </p:nvPr>
-        </p:nvSpPr>
-        <p:spPr/>
-      </p:sp>
-      <p:sp>
-        <p:nvSpPr>
-          <p:cNvPr id="3" name="Notes Placeholder 2"/>
-          <p:cNvSpPr>
-            <a:spLocks noGrp="1"/>
-          </p:cNvSpPr>
-          <p:nvPr>
-            <p:ph type="body" idx="1"/>
-          </p:nvPr>
-        </p:nvSpPr>
-        <p:spPr/>
-        <p:txBody>
-          <a:bodyPr/>
-          <a:lstStyle/>
-          <a:p>
-            <a:r>
-              <a:rPr lang="en-US" dirty="0"/>
-              <a:t>• [Your story: anything you'd change about PRIME in hindsight.]
-• Land the closing line slowly; it's the bridge to the role.</a:t>
-            </a:r>
-            <a:endParaRPr lang="en-US" dirty="0"/>
-          </a:p>
-        </p:txBody>
-      </p:sp>
-      <p:sp>
-        <p:nvSpPr>
-          <p:cNvPr id="4" name="Slide Number Placeholder 3"/>
-          <p:cNvSpPr>
-            <a:spLocks noGrp="1"/>
-          </p:cNvSpPr>
-          <p:nvPr>
-            <p:ph type="sldNum" sz="quarter" idx="10"/>
-          </p:nvPr>
-        </p:nvSpPr>
-        <p:spPr/>
-        <p:txBody>
-          <a:bodyPr/>
-          <a:lstStyle/>
-          <a:p>
-            <a:fld id="{F7021451-1387-4CA6-816F-3879F97B5CBC}" type="slidenum">
-              <a:rPr lang="en-US"/>
-              <a:t>15</a:t>
-            </a:fld>
-            <a:endParaRPr lang="en-US"/>
-          </a:p>
-        </p:txBody>
-      </p:sp>
-    </p:spTree>
-    <p:extLst>
-      <p:ext uri="{BB962C8B-B14F-4D97-AF65-F5344CB8AC3E}">
-        <p14:creationId xmlns:p14="http://schemas.microsoft.com/office/powerpoint/2010/main" val="1024086991"/>
-      </p:ext>
-    </p:extLst>
-  </p:cSld>
-  <p:clrMapOvr>
-    <a:masterClrMapping/>
-  </p:clrMapOvr>
-</p:notes>
-</file>
-
-<file path=ppt/notesSlides/notesSlide16.xml><?xml version="1.0" encoding="utf-8"?>
-<p:notes xmlns:a="http://schemas.openxmlformats.org/drawingml/2006/main" xmlns:r="http://schemas.openxmlformats.org/officeDocument/2006/relationships" xmlns:p="http://schemas.openxmlformats.org/presentationml/2006/main">
-  <p:cSld>
-    <p:spTree>
-      <p:nvGrpSpPr>
-        <p:cNvPr id="1" name=""/>
-        <p:cNvGrpSpPr/>
-        <p:nvPr/>
-      </p:nvGrpSpPr>
-      <p:grpSpPr>
-        <a:xfrm>
-          <a:off x="0" y="0"/>
-          <a:ext cx="0" cy="0"/>
-          <a:chOff x="0" y="0"/>
-          <a:chExt cx="0" cy="0"/>
-        </a:xfrm>
-      </p:grpSpPr>
-      <p:sp>
-        <p:nvSpPr>
-          <p:cNvPr id="2" name="Slide Image Placeholder 1"/>
-          <p:cNvSpPr>
-            <a:spLocks noGrp="1" noRot="1" noChangeAspect="1"/>
-          </p:cNvSpPr>
-          <p:nvPr>
-            <p:ph type="sldImg"/>
-          </p:nvPr>
-        </p:nvSpPr>
-        <p:spPr/>
-      </p:sp>
-      <p:sp>
-        <p:nvSpPr>
-          <p:cNvPr id="3" name="Notes Placeholder 2"/>
-          <p:cNvSpPr>
-            <a:spLocks noGrp="1"/>
-          </p:cNvSpPr>
-          <p:nvPr>
-            <p:ph type="body" idx="1"/>
-          </p:nvPr>
-        </p:nvSpPr>
-        <p:spPr/>
-        <p:txBody>
-          <a:bodyPr/>
-          <a:lstStyle/>
-          <a:p>
-            <a:r>
-              <a:rPr lang="en-US" dirty="0"/>
-              <a:t>• Stop talking. Leave this slide up during questions.</a:t>
-            </a:r>
-            <a:endParaRPr lang="en-US" dirty="0"/>
-          </a:p>
-        </p:txBody>
-      </p:sp>
-      <p:sp>
-        <p:nvSpPr>
-          <p:cNvPr id="4" name="Slide Number Placeholder 3"/>
-          <p:cNvSpPr>
-            <a:spLocks noGrp="1"/>
-          </p:cNvSpPr>
-          <p:nvPr>
-            <p:ph type="sldNum" sz="quarter" idx="10"/>
-          </p:nvPr>
-        </p:nvSpPr>
-        <p:spPr/>
-        <p:txBody>
-          <a:bodyPr/>
-          <a:lstStyle/>
-          <a:p>
-            <a:fld id="{F7021451-1387-4CA6-816F-3879F97B5CBC}" type="slidenum">
-              <a:rPr lang="en-US"/>
-              <a:t>16</a:t>
             </a:fld>
             <a:endParaRPr lang="en-US"/>
           </a:p>
@@ -1227,7 +776,7 @@
           <a:p>
             <a:r>
               <a:rPr lang="en-US" dirty="0"/>
-              <a:t>• Twenty seconds. The tag in the top-left of every slide tells the panel which question it answers.</a:t>
+              <a:t>• Fifteen seconds. The tag on each slide shows which of your questions it answers.</a:t>
             </a:r>
             <a:endParaRPr lang="en-US" dirty="0"/>
           </a:p>
@@ -1315,8 +864,9 @@
           <a:p>
             <a:r>
               <a:rPr lang="en-US" dirty="0"/>
-              <a:t>• [Your story: one concrete moment where inconsistent numbers caused a real problem with a client or internally.]
-• Bridge to the City: siloed client databases look a lot like departments that each run their own system. The questions that matter cut across them.</a:t>
+              <a:t>• Customer Success, Product and clients each had their own number, so meetings argued about whose was right.
+• [Your story: one concrete moment where this hurt.]
+• City link: departments with their own systems face the same thing. The useful questions cut across them.</a:t>
             </a:r>
             <a:endParaRPr lang="en-US" dirty="0"/>
           </a:p>
@@ -1404,8 +954,8 @@
           <a:p>
             <a:r>
               <a:rPr lang="en-US" dirty="0"/>
-              <a:t>• [Your story: how you gathered these. Interviews, shadowing CS, reviewing the engineering ticket queue, client feedback?]
-• The point to land: I didn't start from the technology. Every design choice traces back to one of these rows.</a:t>
+              <a:t>• Users: Customer Success, Product, clients, analysts, and later AI assistants.
+• [Your story: how you gathered these. Interviews, the ticket queue, client feedback?]</a:t>
             </a:r>
             <a:endParaRPr lang="en-US" dirty="0"/>
           </a:p>
@@ -1493,8 +1043,8 @@
           <a:p>
             <a:r>
               <a:rPr lang="en-US" dirty="0"/>
-              <a:t>• Tie each decision back to a requirement on the previous slide: consolidate → one definition; contract → owners and freshness; grain → AI; internal first → trust before scale.
-• [Your story: any option you considered and rejected, e.g. fixing reports one by one.]</a:t>
+              <a:t>• Each decision maps to a need on the last slide.
+• [Your story: confirm the real order, and an option you rejected.]</a:t>
             </a:r>
             <a:endParaRPr lang="en-US" dirty="0"/>
           </a:p>
@@ -1582,8 +1132,8 @@
           <a:p>
             <a:r>
               <a:rPr lang="en-US" dirty="0"/>
-              <a:t>• [Your story: confirm the real order and roughly how long each step took.]
-• Why this order: each step delivers something people can use, so value shows up before the whole thing is finished.</a:t>
+              <a:t>• How people use it: a CS manager asks 'how did ticket revenue trend this month?' and the agent answers from the table with the right grain.
+• [Your story: what you personally decided as product owner.]</a:t>
             </a:r>
             <a:endParaRPr lang="en-US" dirty="0"/>
           </a:p>
@@ -1671,8 +1221,7 @@
           <a:p>
             <a:r>
               <a:rPr lang="en-US" dirty="0"/>
-              <a:t>• Tools: Snowflake, dbt (100+ tested models), Airflow, AWS, a semantic layer and LLMs.
-• [Your story: what you personally decided as product owner, and how you kept the pod aligned.]</a:t>
+              <a:t>• [Your story: any adoption or time-saved number you can share.] Pause, then: 'Let me show you this working.'</a:t>
             </a:r>
             <a:endParaRPr lang="en-US" dirty="0"/>
           </a:p>
@@ -1760,7 +1309,11 @@
           <a:p>
             <a:r>
               <a:rPr lang="en-US" dirty="0"/>
-              <a:t>• Keep it quick: the live version of this is coming on Calgary data.</a:t>
+              <a:t>• LIVE (4 min). Switch to the Dashboard tab.
+• 1 · Read the headline. Point at the trips line: the 2020 drop and the recovery. (1 min)
+• 2 · The 311 chart. 'My first cut said complaints per trip were up 43%. That felt too dramatic, so I checked. Lost Property moved into 311 in 2021. I fixed it in the data, once, so the dashboard and the AI both get it right. Like for like it's 12%, led by fares and stops.' (1 min)
+• 3 · Ask the data: click 'How has ridership recovered since the pandemic?'. While it runs: 'it reads the dbt docs, writes SQL, and runs it here in the browser on governed tables only.' Show the SQL, then point at the same 95% on the dashboard. (1.5 min)
+• If asked how it's built: open the Approach page and the Airflow graph. Otherwise skip it.</a:t>
             </a:r>
             <a:endParaRPr lang="en-US" dirty="0"/>
           </a:p>
@@ -1848,8 +1401,7 @@
           <a:p>
             <a:r>
               <a:rPr lang="en-US" dirty="0"/>
-              <a:t>• Value: CS, Product and clients work from the same numbers on a reliable schedule, and routine questions no longer need an engineering ticket.
-• [Your story: feedback from users that changed the design, and any adoption or time-saved numbers you can share.]</a:t>
+              <a:t>• [Your story: the conversation that got the data contract agreed. Who pushed back, and what changed their mind?]</a:t>
             </a:r>
             <a:endParaRPr lang="en-US" dirty="0"/>
           </a:p>
@@ -2316,251 +1868,6 @@
       <p:pic>
         <p:nvPicPr>
           <p:cNvPr id="2" name="Image 0" descr="Slide 11">    </p:cNvPr>
-          <p:cNvPicPr>
-            <a:picLocks noChangeAspect="1"/>
-          </p:cNvPicPr>
-          <p:nvPr/>
-        </p:nvPicPr>
-        <p:blipFill>
-          <a:blip r:embed="rId1"/>
-          <a:stretch>
-            <a:fillRect/>
-          </a:stretch>
-        </p:blipFill>
-        <p:spPr>
-          <a:xfrm>
-            <a:off x="0" y="0"/>
-            <a:ext cx="9144000" cy="5143500"/>
-          </a:xfrm>
-          <a:prstGeom prst="rect">
-            <a:avLst/>
-          </a:prstGeom>
-        </p:spPr>
-      </p:pic>
-    </p:spTree>
-  </p:cSld>
-  <p:clrMapOvr>
-    <a:masterClrMapping/>
-  </p:clrMapOvr>
-</p:sld>
-</file>
-
-<file path=ppt/slides/slide12.xml><?xml version="1.0" encoding="utf-8"?>
-<p:sld xmlns:a="http://schemas.openxmlformats.org/drawingml/2006/main" xmlns:r="http://schemas.openxmlformats.org/officeDocument/2006/relationships" xmlns:p="http://schemas.openxmlformats.org/presentationml/2006/main">
-  <p:cSld name="Slide 12">
-    <p:spTree>
-      <p:nvGrpSpPr>
-        <p:cNvPr id="1" name=""/>
-        <p:cNvGrpSpPr/>
-        <p:nvPr/>
-      </p:nvGrpSpPr>
-      <p:grpSpPr>
-        <a:xfrm>
-          <a:off x="0" y="0"/>
-          <a:ext cx="0" cy="0"/>
-          <a:chOff x="0" y="0"/>
-          <a:chExt cx="0" cy="0"/>
-        </a:xfrm>
-      </p:grpSpPr>
-      <p:pic>
-        <p:nvPicPr>
-          <p:cNvPr id="2" name="Image 0" descr="Slide 12">    </p:cNvPr>
-          <p:cNvPicPr>
-            <a:picLocks noChangeAspect="1"/>
-          </p:cNvPicPr>
-          <p:nvPr/>
-        </p:nvPicPr>
-        <p:blipFill>
-          <a:blip r:embed="rId1"/>
-          <a:stretch>
-            <a:fillRect/>
-          </a:stretch>
-        </p:blipFill>
-        <p:spPr>
-          <a:xfrm>
-            <a:off x="0" y="0"/>
-            <a:ext cx="9144000" cy="5143500"/>
-          </a:xfrm>
-          <a:prstGeom prst="rect">
-            <a:avLst/>
-          </a:prstGeom>
-        </p:spPr>
-      </p:pic>
-    </p:spTree>
-  </p:cSld>
-  <p:clrMapOvr>
-    <a:masterClrMapping/>
-  </p:clrMapOvr>
-</p:sld>
-</file>
-
-<file path=ppt/slides/slide13.xml><?xml version="1.0" encoding="utf-8"?>
-<p:sld xmlns:a="http://schemas.openxmlformats.org/drawingml/2006/main" xmlns:r="http://schemas.openxmlformats.org/officeDocument/2006/relationships" xmlns:p="http://schemas.openxmlformats.org/presentationml/2006/main">
-  <p:cSld name="Slide 13">
-    <p:spTree>
-      <p:nvGrpSpPr>
-        <p:cNvPr id="1" name=""/>
-        <p:cNvGrpSpPr/>
-        <p:nvPr/>
-      </p:nvGrpSpPr>
-      <p:grpSpPr>
-        <a:xfrm>
-          <a:off x="0" y="0"/>
-          <a:ext cx="0" cy="0"/>
-          <a:chOff x="0" y="0"/>
-          <a:chExt cx="0" cy="0"/>
-        </a:xfrm>
-      </p:grpSpPr>
-      <p:pic>
-        <p:nvPicPr>
-          <p:cNvPr id="2" name="Image 0" descr="Slide 13">    </p:cNvPr>
-          <p:cNvPicPr>
-            <a:picLocks noChangeAspect="1"/>
-          </p:cNvPicPr>
-          <p:nvPr/>
-        </p:nvPicPr>
-        <p:blipFill>
-          <a:blip r:embed="rId1"/>
-          <a:stretch>
-            <a:fillRect/>
-          </a:stretch>
-        </p:blipFill>
-        <p:spPr>
-          <a:xfrm>
-            <a:off x="0" y="0"/>
-            <a:ext cx="9144000" cy="5143500"/>
-          </a:xfrm>
-          <a:prstGeom prst="rect">
-            <a:avLst/>
-          </a:prstGeom>
-        </p:spPr>
-      </p:pic>
-    </p:spTree>
-  </p:cSld>
-  <p:clrMapOvr>
-    <a:masterClrMapping/>
-  </p:clrMapOvr>
-</p:sld>
-</file>
-
-<file path=ppt/slides/slide14.xml><?xml version="1.0" encoding="utf-8"?>
-<p:sld xmlns:a="http://schemas.openxmlformats.org/drawingml/2006/main" xmlns:r="http://schemas.openxmlformats.org/officeDocument/2006/relationships" xmlns:p="http://schemas.openxmlformats.org/presentationml/2006/main">
-  <p:cSld name="Slide 14">
-    <p:spTree>
-      <p:nvGrpSpPr>
-        <p:cNvPr id="1" name=""/>
-        <p:cNvGrpSpPr/>
-        <p:nvPr/>
-      </p:nvGrpSpPr>
-      <p:grpSpPr>
-        <a:xfrm>
-          <a:off x="0" y="0"/>
-          <a:ext cx="0" cy="0"/>
-          <a:chOff x="0" y="0"/>
-          <a:chExt cx="0" cy="0"/>
-        </a:xfrm>
-      </p:grpSpPr>
-      <p:pic>
-        <p:nvPicPr>
-          <p:cNvPr id="2" name="Image 0" descr="Slide 14">    </p:cNvPr>
-          <p:cNvPicPr>
-            <a:picLocks noChangeAspect="1"/>
-          </p:cNvPicPr>
-          <p:nvPr/>
-        </p:nvPicPr>
-        <p:blipFill>
-          <a:blip r:embed="rId1"/>
-          <a:stretch>
-            <a:fillRect/>
-          </a:stretch>
-        </p:blipFill>
-        <p:spPr>
-          <a:xfrm>
-            <a:off x="0" y="0"/>
-            <a:ext cx="9144000" cy="5143500"/>
-          </a:xfrm>
-          <a:prstGeom prst="rect">
-            <a:avLst/>
-          </a:prstGeom>
-        </p:spPr>
-      </p:pic>
-    </p:spTree>
-  </p:cSld>
-  <p:clrMapOvr>
-    <a:masterClrMapping/>
-  </p:clrMapOvr>
-</p:sld>
-</file>
-
-<file path=ppt/slides/slide15.xml><?xml version="1.0" encoding="utf-8"?>
-<p:sld xmlns:a="http://schemas.openxmlformats.org/drawingml/2006/main" xmlns:r="http://schemas.openxmlformats.org/officeDocument/2006/relationships" xmlns:p="http://schemas.openxmlformats.org/presentationml/2006/main">
-  <p:cSld name="Slide 15">
-    <p:spTree>
-      <p:nvGrpSpPr>
-        <p:cNvPr id="1" name=""/>
-        <p:cNvGrpSpPr/>
-        <p:nvPr/>
-      </p:nvGrpSpPr>
-      <p:grpSpPr>
-        <a:xfrm>
-          <a:off x="0" y="0"/>
-          <a:ext cx="0" cy="0"/>
-          <a:chOff x="0" y="0"/>
-          <a:chExt cx="0" cy="0"/>
-        </a:xfrm>
-      </p:grpSpPr>
-      <p:pic>
-        <p:nvPicPr>
-          <p:cNvPr id="2" name="Image 0" descr="Slide 15">    </p:cNvPr>
-          <p:cNvPicPr>
-            <a:picLocks noChangeAspect="1"/>
-          </p:cNvPicPr>
-          <p:nvPr/>
-        </p:nvPicPr>
-        <p:blipFill>
-          <a:blip r:embed="rId1"/>
-          <a:stretch>
-            <a:fillRect/>
-          </a:stretch>
-        </p:blipFill>
-        <p:spPr>
-          <a:xfrm>
-            <a:off x="0" y="0"/>
-            <a:ext cx="9144000" cy="5143500"/>
-          </a:xfrm>
-          <a:prstGeom prst="rect">
-            <a:avLst/>
-          </a:prstGeom>
-        </p:spPr>
-      </p:pic>
-    </p:spTree>
-  </p:cSld>
-  <p:clrMapOvr>
-    <a:masterClrMapping/>
-  </p:clrMapOvr>
-</p:sld>
-</file>
-
-<file path=ppt/slides/slide16.xml><?xml version="1.0" encoding="utf-8"?>
-<p:sld xmlns:a="http://schemas.openxmlformats.org/drawingml/2006/main" xmlns:r="http://schemas.openxmlformats.org/officeDocument/2006/relationships" xmlns:p="http://schemas.openxmlformats.org/presentationml/2006/main">
-  <p:cSld name="Slide 16">
-    <p:spTree>
-      <p:nvGrpSpPr>
-        <p:cNvPr id="1" name=""/>
-        <p:cNvGrpSpPr/>
-        <p:nvPr/>
-      </p:nvGrpSpPr>
-      <p:grpSpPr>
-        <a:xfrm>
-          <a:off x="0" y="0"/>
-          <a:ext cx="0" cy="0"/>
-          <a:chOff x="0" y="0"/>
-          <a:chExt cx="0" cy="0"/>
-        </a:xfrm>
-      </p:grpSpPr>
-      <p:pic>
-        <p:nvPicPr>
-          <p:cNvPr id="2" name="Image 0" descr="Slide 16">    </p:cNvPr>
           <p:cNvPicPr>
             <a:picLocks noChangeAspect="1"/>
           </p:cNvPicPr>

</xml_diff>

<commit_message>
Calgary Transit demo: live XGBoost prediction, and the dashboard headline as an info tip
Airflow now trains a classifier after the dbt tests: will a transit 311 request be closed
within 7 days? It uses only what's known at filing time, is tested on 2025 (a year it never
saw) against each request type's past rate, and its exported trees are checked against
XGBoost on every run. The new Predict page scores and explains it live in the browser.
The dashboard's headline moves into an info icon so the tiles sit under the title.

Co-Authored-By: Claude Opus 5.5 <noreply@anthropic.com>
</commit_message>
<xml_diff>
--- a/demos/calgary-transit/web/public/downloads/prime-case-study.pptx
+++ b/demos/calgary-transit/web/public/downloads/prime-case-study.pptx
@@ -1309,10 +1309,11 @@
           <a:p>
             <a:r>
               <a:rPr lang="en-US" dirty="0"/>
-              <a:t>• LIVE (4 min). Switch to the Dashboard tab.
+              <a:t>• LIVE (5 min). Switch to the Dashboard tab.
 • 1 · Read the headline. Point at the trips line: the 2020 drop and the recovery. (1 min)
 • 2 · The 311 chart. 'My first cut said complaints per trip were up 43%. That felt too dramatic, so I checked. Lost Property moved into 311 in 2021. I fixed it in the data, once, so the dashboard and the AI both get it right. Like for like it's 12%, led by fares and stops.' (1 min)
-• 3 · Ask the data: click 'How has ridership recovered since the pandemic?'. While it runs: 'it reads the dbt docs, writes SQL, and runs it here in the browser on governed tables only.' Show the SQL, then point at the same 95% on the dashboard. (1.5 min)
+• 3 · Predict tab: 'Same governed tables, now ML.' Pick Bus Stops: about 45%, likely slower. 'The biggest driver is how fast this type has been handled lately, more than the type itself.' Switch to Transit Pass Programs and watch it jump to about 80%. Then the honest part: 'Tested on 2025, a year it never saw, it beats the simple rule of thumb by a couple of points, and it explains every prediction.' (1 min)
+• 4 · Ask the data: click 'How has ridership recovered since the pandemic?'. While it runs: 'it reads the dbt docs, writes SQL, and runs it here in the browser on governed tables only.' Show the SQL, then point at the same 95% on the dashboard. (1.5 min)
 • If asked how it's built: open the Approach page and the Airflow graph. Otherwise skip it.</a:t>
             </a:r>
             <a:endParaRPr lang="en-US" dirty="0"/>

</xml_diff>

<commit_message>
Deck answers the six questions explicitly; lineage graph generated from dbt
Each slide is titled with one of the panel's questions and answers its parts (a, b, c),
with real dashboard and prediction screenshots on the demo slide. The approach page swaps
the old Airflow screenshot for a lineage diagram built from the dbt manifest on every run,
so it matches the dbt docs, plus the ML model and the pages that use the data.

Co-Authored-By: Claude Opus 5.5 <noreply@anthropic.com>
</commit_message>
<xml_diff>
--- a/demos/calgary-transit/web/public/downloads/prime-case-study.pptx
+++ b/demos/calgary-transit/web/public/downloads/prime-case-study.pptx
@@ -512,7 +512,7 @@
           <a:p>
             <a:r>
               <a:rPr lang="en-US" dirty="0"/>
-              <a:t>• [Your story: one line on who you are.] Then: 'I'll walk through PRIME, then show you the same approach working on the City's data.'</a:t>
+              <a:t>• [Your story: one line on who you are.] Then: 'I'll answer your six questions in order, with a live demo in the middle.'</a:t>
             </a:r>
             <a:endParaRPr lang="en-US" dirty="0"/>
           </a:p>
@@ -776,7 +776,7 @@
           <a:p>
             <a:r>
               <a:rPr lang="en-US" dirty="0"/>
-              <a:t>• Fifteen seconds. The tag on each slide shows which of your questions it answers.</a:t>
+              <a:t>• Fifteen seconds. Each slide's title is one of their questions.</a:t>
             </a:r>
             <a:endParaRPr lang="en-US" dirty="0"/>
           </a:p>
@@ -864,9 +864,8 @@
           <a:p>
             <a:r>
               <a:rPr lang="en-US" dirty="0"/>
-              <a:t>• Customer Success, Product and clients each had their own number, so meetings argued about whose was right.
-• [Your story: one concrete moment where this hurt.]
-• City link: departments with their own systems face the same thing. The useful questions cut across them.</a:t>
+              <a:t>• [Your story: one concrete moment where inconsistent numbers hurt.]
+• City link: departments with their own systems face the same thing.</a:t>
             </a:r>
             <a:endParaRPr lang="en-US" dirty="0"/>
           </a:p>
@@ -954,8 +953,8 @@
           <a:p>
             <a:r>
               <a:rPr lang="en-US" dirty="0"/>
-              <a:t>• Users: Customer Success, Product, clients, analysts, and later AI assistants.
-• [Your story: how you gathered these. Interviews, the ticket queue, client feedback?]</a:t>
+              <a:t>• My role: Director of Product Innovation &amp; Analytics; I owned PRIME from planning to general availability, working with Data Engineering and Customer Success.
+• Plain-English example: 'How did ticket revenue trend this month?' answered from the table with the right grain.</a:t>
             </a:r>
             <a:endParaRPr lang="en-US" dirty="0"/>
           </a:p>
@@ -1043,8 +1042,7 @@
           <a:p>
             <a:r>
               <a:rPr lang="en-US" dirty="0"/>
-              <a:t>• Each decision maps to a need on the last slide.
-• [Your story: confirm the real order, and an option you rejected.]</a:t>
+              <a:t>• [Your story: any adoption or time-saved number.]</a:t>
             </a:r>
             <a:endParaRPr lang="en-US" dirty="0"/>
           </a:p>
@@ -1132,8 +1130,9 @@
           <a:p>
             <a:r>
               <a:rPr lang="en-US" dirty="0"/>
-              <a:t>• How people use it: a CS manager asks 'how did ticket revenue trend this month?' and the agent answers from the table with the right grain.
-• [Your story: what you personally decided as product owner.]</a:t>
+              <a:t>• Walk the strip in one breath: started from the problem and the people, agreed what 'right' means, then built, tested and fixed what review found.
+• [Your story: how you gathered requirements, and the real build order.]
+• Transition: 'Here's the same approach running on the City's data.'</a:t>
             </a:r>
             <a:endParaRPr lang="en-US" dirty="0"/>
           </a:p>
@@ -1221,7 +1220,11 @@
           <a:p>
             <a:r>
               <a:rPr lang="en-US" dirty="0"/>
-              <a:t>• [Your story: any adoption or time-saved number you can share.] Pause, then: 'Let me show you this working.'</a:t>
+              <a:t>• LIVE (5 min). If the internet fails, these screenshots carry it.
+• 1 · Dashboard: read the ⓘ headline. Point at the 2020 drop and recovery. (1 min)
+• 2 · The 311 chart: 'My first cut said complaints per trip were up 43%. Lost Property moved into 311 in 2021. I fixed it once, in the data, so the dashboard and the AI both get it right. Like for like it's 12%.' (1 min)
+• 3 · Predict: pick Advertising and Communications (usually low), then Transit Pass Programs (usually high). Recent pace matters more than the type. Tested on 2025, it catches more slow requests than the rule of thumb. (1 min)
+• 4 · Ask the data: 'How has ridership recovered since the pandemic?'. Open 'Show how this was answered', then point at the same 95% on the dashboard. (1.5 min)</a:t>
             </a:r>
             <a:endParaRPr lang="en-US" dirty="0"/>
           </a:p>
@@ -1309,12 +1312,7 @@
           <a:p>
             <a:r>
               <a:rPr lang="en-US" dirty="0"/>
-              <a:t>• LIVE (5 min). Switch to the Dashboard tab.
-• 1 · Read the headline. Point at the trips line: the 2020 drop and the recovery. (1 min)
-• 2 · The 311 chart. 'My first cut said complaints per trip were up 43%. That felt too dramatic, so I checked. Lost Property moved into 311 in 2021. I fixed it in the data, once, so the dashboard and the AI both get it right. Like for like it's 12%, led by fares and stops.' (1 min)
-• 3 · Predict tab: 'Same governed tables, now ML.' Pick Advertising and Communications (usually low), then Transit Pass Programs (usually high), and point at what moved it: recent pace matters more than the type itself. Then the honest part: 'Tested on 2025, a year it never saw, it catches more slow requests than the rule of thumb and explains every prediction.' Numbers shift a little each day because it retrains daily. (1 min)
-• 4 · Ask the data: click 'How has ridership recovered since the pandemic?'. While it runs: 'it reads the dbt docs, writes SQL, and runs it here in the browser on governed tables only.' Show the SQL, then point at the same 95% on the dashboard. (1.5 min)
-• If asked how it's built: open the Approach page and the Airflow graph. Otherwise skip it.</a:t>
+              <a:t>• [Your story: the conversation that got the data contract agreed. Who pushed back, and what changed their mind?]</a:t>
             </a:r>
             <a:endParaRPr lang="en-US" dirty="0"/>
           </a:p>
@@ -1402,7 +1400,7 @@
           <a:p>
             <a:r>
               <a:rPr lang="en-US" dirty="0"/>
-              <a:t>• [Your story: the conversation that got the data contract agreed. Who pushed back, and what changed their mind?]</a:t>
+              <a:t>• You've just shown it live, so keep this to 30 to 45 seconds.</a:t>
             </a:r>
             <a:endParaRPr lang="en-US" dirty="0"/>
           </a:p>

</xml_diff>

<commit_message>
Calgary Transit: chart with each Ask answer, neutral loading text, tighter deck
Ask answers now show a line or bar chart of the result. Loading text no longer
names the model. Deck: Q5 points back to the demo instead of repeating it, Q4
analytical row is about PRIME, the data contract lives only in Q4, and the demo
notes match the current UI. Exports regenerated.

Co-Authored-By: Claude Opus 5.5 <noreply@anthropic.com>
</commit_message>
<xml_diff>
--- a/demos/calgary-transit/web/public/downloads/prime-case-study.pptx
+++ b/demos/calgary-transit/web/public/downloads/prime-case-study.pptx
@@ -1222,9 +1222,10 @@
               <a:rPr lang="en-US" dirty="0"/>
               <a:t>• LIVE (5 min). If the internet fails, these screenshots carry it.
 • 1 · Dashboard: read the ⓘ headline. Point at the 2020 drop and recovery. (1 min)
-• 2 · The 311 chart: 'My first cut said complaints per trip were up 43%. Lost Property moved into 311 in 2021. I fixed it once, in the data, so the dashboard and the AI both get it right. Like for like it's 12%.' (1 min)
+• 2 · The 311 chart: 'My first cut said complaints per trip were up 43%. Lost Property moved into 311 in 2021. I fixed it once, in the data, so every consumer gets it right. Like for like it's 12%.' (1 min)
 • 3 · Predict: pick Advertising and Communications (usually low), then Transit Pass Programs (usually high). Recent pace matters more than the type. Tested on 2025, it catches more slow requests than the rule of thumb. (1 min)
-• 4 · Ask the data: 'How has ridership recovered since the pandemic?'. Open 'Show how this was answered', then point at the same 95% on the dashboard. (1.5 min)</a:t>
+• 4 · Ask the data: type 'How has ridership recovered since the pandemic?' and say 'it writes SQL against the same gold tables' while it works. Read the answer, glance at the chart, open 'Show how this was answered'. Payoff: 'Same 95% as the dashboard. That's the point I made about PRIME.' (1.5 min)
+• Back to the deck: 'So that's what PRIME looks like in practice. Here's what was hard.'</a:t>
             </a:r>
             <a:endParaRPr lang="en-US" dirty="0"/>
           </a:p>
@@ -1312,7 +1313,8 @@
           <a:p>
             <a:r>
               <a:rPr lang="en-US" dirty="0"/>
-              <a:t>• [Your story: the conversation that got the data contract agreed. Who pushed back, and what changed their mind?]</a:t>
+              <a:t>• Analytical row: one line back to the demo ('Lost Property was this problem in miniature'). Don't re-explain it.
+• [Your story: the conversation that got the data contract agreed. Who pushed back, and what changed their mind?]</a:t>
             </a:r>
             <a:endParaRPr lang="en-US" dirty="0"/>
           </a:p>
@@ -1400,7 +1402,8 @@
           <a:p>
             <a:r>
               <a:rPr lang="en-US" dirty="0"/>
-              <a:t>• You've just shown it live, so keep this to 30 to 45 seconds.</a:t>
+              <a:t>• 30 to 45 seconds. Point back at the demo; don't re-demo it.
+• [Your story: the first time a team trusted an AI answer without checking it.]</a:t>
             </a:r>
             <a:endParaRPr lang="en-US" dirty="0"/>
           </a:p>

</xml_diff>

<commit_message>
Deck: tell PRIME as a STAR story, drop the City data demo
Twelve slides, about 13 minutes. Situation, Task, Action and Result each map to
the panel's six questions, with a STAR tracker in every slide header. Task sets
five requirements that the Result slide checks off. The live demo slide and its
screenshots are removed. Exports regenerated.

Co-Authored-By: Claude Opus 5.5 <noreply@anthropic.com>
</commit_message>
<xml_diff>
--- a/demos/calgary-transit/web/public/downloads/prime-case-study.pptx
+++ b/demos/calgary-transit/web/public/downloads/prime-case-study.pptx
@@ -16,9 +16,10 @@
     <p:sldId id="264" r:id="rId10"/>
     <p:sldId id="265" r:id="rId11"/>
     <p:sldId id="266" r:id="rId12"/>
+    <p:sldId id="267" r:id="rId13"/>
   </p:sldIdLst>
   <p:notesMasterIdLst>
-    <p:notesMasterId r:id="rId13"/>
+    <p:notesMasterId r:id="rId14"/>
   </p:notesMasterIdLst>
   <p:sldSz cx="9144000" cy="5143500"/>
   <p:notesSz cx="5143500" cy="9144000"/>
@@ -512,7 +513,8 @@
           <a:p>
             <a:r>
               <a:rPr lang="en-US" dirty="0"/>
-              <a:t>• [Your story: one line on who you are.] Then: 'I'll answer your six questions in order, with a live demo in the middle.'</a:t>
+              <a:t>• [Your story: one line on who you are.]
+• Then: 'I'll tell this as a STAR story. Each part answers your questions in order.'</a:t>
             </a:r>
             <a:endParaRPr lang="en-US" dirty="0"/>
           </a:p>
@@ -600,7 +602,8 @@
           <a:p>
             <a:r>
               <a:rPr lang="en-US" dirty="0"/>
-              <a:t>• Land the closing line slowly. It's the bridge to the role.</a:t>
+              <a:t>• Slow down here. This is the line to remember.
+• [Your story: the first time a team trusted an answer without double-checking it.]</a:t>
             </a:r>
             <a:endParaRPr lang="en-US" dirty="0"/>
           </a:p>
@@ -688,6 +691,95 @@
           <a:p>
             <a:r>
               <a:rPr lang="en-US" dirty="0"/>
+              <a:t>• [Your story: swap in whatever you'd genuinely do differently.]
+• Land the closing line slowly. It's the bridge to the role.</a:t>
+            </a:r>
+            <a:endParaRPr lang="en-US" dirty="0"/>
+          </a:p>
+        </p:txBody>
+      </p:sp>
+      <p:sp>
+        <p:nvSpPr>
+          <p:cNvPr id="4" name="Slide Number Placeholder 3"/>
+          <p:cNvSpPr>
+            <a:spLocks noGrp="1"/>
+          </p:cNvSpPr>
+          <p:nvPr>
+            <p:ph type="sldNum" sz="quarter" idx="10"/>
+          </p:nvPr>
+        </p:nvSpPr>
+        <p:spPr/>
+        <p:txBody>
+          <a:bodyPr/>
+          <a:lstStyle/>
+          <a:p>
+            <a:fld id="{F7021451-1387-4CA6-816F-3879F97B5CBC}" type="slidenum">
+              <a:rPr lang="en-US"/>
+              <a:t>11</a:t>
+            </a:fld>
+            <a:endParaRPr lang="en-US"/>
+          </a:p>
+        </p:txBody>
+      </p:sp>
+    </p:spTree>
+    <p:extLst>
+      <p:ext uri="{BB962C8B-B14F-4D97-AF65-F5344CB8AC3E}">
+        <p14:creationId xmlns:p14="http://schemas.microsoft.com/office/powerpoint/2010/main" val="1024086991"/>
+      </p:ext>
+    </p:extLst>
+  </p:cSld>
+  <p:clrMapOvr>
+    <a:masterClrMapping/>
+  </p:clrMapOvr>
+</p:notes>
+</file>
+
+<file path=ppt/notesSlides/notesSlide12.xml><?xml version="1.0" encoding="utf-8"?>
+<p:notes xmlns:a="http://schemas.openxmlformats.org/drawingml/2006/main" xmlns:r="http://schemas.openxmlformats.org/officeDocument/2006/relationships" xmlns:p="http://schemas.openxmlformats.org/presentationml/2006/main">
+  <p:cSld>
+    <p:spTree>
+      <p:nvGrpSpPr>
+        <p:cNvPr id="1" name=""/>
+        <p:cNvGrpSpPr/>
+        <p:nvPr/>
+      </p:nvGrpSpPr>
+      <p:grpSpPr>
+        <a:xfrm>
+          <a:off x="0" y="0"/>
+          <a:ext cx="0" cy="0"/>
+          <a:chOff x="0" y="0"/>
+          <a:chExt cx="0" cy="0"/>
+        </a:xfrm>
+      </p:grpSpPr>
+      <p:sp>
+        <p:nvSpPr>
+          <p:cNvPr id="2" name="Slide Image Placeholder 1"/>
+          <p:cNvSpPr>
+            <a:spLocks noGrp="1" noRot="1" noChangeAspect="1"/>
+          </p:cNvSpPr>
+          <p:nvPr>
+            <p:ph type="sldImg"/>
+          </p:nvPr>
+        </p:nvSpPr>
+        <p:spPr/>
+      </p:sp>
+      <p:sp>
+        <p:nvSpPr>
+          <p:cNvPr id="3" name="Notes Placeholder 2"/>
+          <p:cNvSpPr>
+            <a:spLocks noGrp="1"/>
+          </p:cNvSpPr>
+          <p:nvPr>
+            <p:ph type="body" idx="1"/>
+          </p:nvPr>
+        </p:nvSpPr>
+        <p:spPr/>
+        <p:txBody>
+          <a:bodyPr/>
+          <a:lstStyle/>
+          <a:p>
+            <a:r>
+              <a:rPr lang="en-US" dirty="0"/>
               <a:t>• Stop talking. Leave this up for questions.</a:t>
             </a:r>
             <a:endParaRPr lang="en-US" dirty="0"/>
@@ -711,7 +803,7 @@
           <a:p>
             <a:fld id="{F7021451-1387-4CA6-816F-3879F97B5CBC}" type="slidenum">
               <a:rPr lang="en-US"/>
-              <a:t>11</a:t>
+              <a:t>12</a:t>
             </a:fld>
             <a:endParaRPr lang="en-US"/>
           </a:p>
@@ -776,7 +868,7 @@
           <a:p>
             <a:r>
               <a:rPr lang="en-US" dirty="0"/>
-              <a:t>• Fifteen seconds. Each slide's title is one of their questions.</a:t>
+              <a:t>• Thirty seconds. Don't read the boxes; just point at the letters.</a:t>
             </a:r>
             <a:endParaRPr lang="en-US" dirty="0"/>
           </a:p>
@@ -864,8 +956,8 @@
           <a:p>
             <a:r>
               <a:rPr lang="en-US" dirty="0"/>
-              <a:t>• [Your story: one concrete moment where inconsistent numbers hurt.]
-• City link: departments with their own systems face the same thing.</a:t>
+              <a:t>• The multi-tenant design was right for the product, but it made internal reporting hard.
+• [Your story: one concrete moment when inconsistent numbers hurt: a client call, a leadership report.]</a:t>
             </a:r>
             <a:endParaRPr lang="en-US" dirty="0"/>
           </a:p>
@@ -953,8 +1045,8 @@
           <a:p>
             <a:r>
               <a:rPr lang="en-US" dirty="0"/>
-              <a:t>• My role: Director of Product Innovation &amp; Analytics; I owned PRIME from planning to general availability, working with Data Engineering and Customer Success.
-• Plain-English example: 'How did ticket revenue trend this month?' answered from the table with the right grain.</a:t>
+              <a:t>• [Your story: how you gathered requirements. Who you talked to, and what they asked for most.]
+• Say: 'These five became the checklist. I'll come back to each one in the results.'</a:t>
             </a:r>
             <a:endParaRPr lang="en-US" dirty="0"/>
           </a:p>
@@ -1042,7 +1134,8 @@
           <a:p>
             <a:r>
               <a:rPr lang="en-US" dirty="0"/>
-              <a:t>• [Your story: any adoption or time-saved number.]</a:t>
+              <a:t>• Walk the flow left to right in one breath. The point: transform once, use everywhere.
+• My part: product owner. I worked with Data Engineering and Customer Success, with a small product pod.</a:t>
             </a:r>
             <a:endParaRPr lang="en-US" dirty="0"/>
           </a:p>
@@ -1130,9 +1223,8 @@
           <a:p>
             <a:r>
               <a:rPr lang="en-US" dirty="0"/>
-              <a:t>• Walk the strip in one breath: started from the problem and the people, agreed what 'right' means, then built, tested and fixed what review found.
-• [Your story: how you gathered requirements, and the real build order.]
-• Transition: 'Here's the same approach running on the City's data.'</a:t>
+              <a:t>• This is the 'show the product' moment. Trace the arrows once.
+• The example question is illustrative. [Your story: a real question the CS bot answered.]</a:t>
             </a:r>
             <a:endParaRPr lang="en-US" dirty="0"/>
           </a:p>
@@ -1220,12 +1312,8 @@
           <a:p>
             <a:r>
               <a:rPr lang="en-US" dirty="0"/>
-              <a:t>• LIVE (5 min). If the internet fails, these screenshots carry it.
-• 1 · Dashboard: read the ⓘ headline. Point at the 2020 drop and recovery. (1 min)
-• 2 · The 311 chart: 'My first cut said complaints per trip were up 43%. Lost Property moved into 311 in 2021. I fixed it once, in the data, so every consumer gets it right. Like for like it's 12%.' (1 min)
-• 3 · Predict: pick Advertising and Communications (usually low), then Transit Pass Programs (usually high). Recent pace matters more than the type. Tested on 2025, it catches more slow requests than the rule of thumb. (1 min)
-• 4 · Ask the data: type 'How has ridership recovered since the pandemic?' and say 'it writes SQL against the same gold tables' while it works. Read the answer, glance at the chart, open 'Show how this was answered'. Payoff: 'Same 95% as the dashboard. That's the point I made about PRIME.' (1.5 min)
-• Back to the deck: 'So that's what PRIME looks like in practice. Here's what was hard.'</a:t>
+              <a:t>• Strategy first, tools last. The panel cares more about the why than the stack.
+• [Your story: the real build order, and what you'd sequence the same way again.]</a:t>
             </a:r>
             <a:endParaRPr lang="en-US" dirty="0"/>
           </a:p>
@@ -1313,7 +1401,7 @@
           <a:p>
             <a:r>
               <a:rPr lang="en-US" dirty="0"/>
-              <a:t>• Analytical row: one line back to the demo ('Lost Property was this problem in miniature'). Don't re-explain it.
+              <a:t>• Spend most of the time on the People row. It's the one an analyst role at the City will relate to.
 • [Your story: the conversation that got the data contract agreed. Who pushed back, and what changed their mind?]</a:t>
             </a:r>
             <a:endParaRPr lang="en-US" dirty="0"/>
@@ -1402,8 +1490,8 @@
           <a:p>
             <a:r>
               <a:rPr lang="en-US" dirty="0"/>
-              <a:t>• 30 to 45 seconds. Point back at the demo; don't re-demo it.
-• [Your story: the first time a team trusted an AI answer without checking it.]</a:t>
+              <a:t>• Tie each result back to the checklist from Task.
+• [Your story: an adoption or time-saved number. A real number beats 'no ticket'.]</a:t>
             </a:r>
             <a:endParaRPr lang="en-US" dirty="0"/>
           </a:p>
@@ -1870,6 +1958,55 @@
       <p:pic>
         <p:nvPicPr>
           <p:cNvPr id="2" name="Image 0" descr="Slide 11">    </p:cNvPr>
+          <p:cNvPicPr>
+            <a:picLocks noChangeAspect="1"/>
+          </p:cNvPicPr>
+          <p:nvPr/>
+        </p:nvPicPr>
+        <p:blipFill>
+          <a:blip r:embed="rId1"/>
+          <a:stretch>
+            <a:fillRect/>
+          </a:stretch>
+        </p:blipFill>
+        <p:spPr>
+          <a:xfrm>
+            <a:off x="0" y="0"/>
+            <a:ext cx="9144000" cy="5143500"/>
+          </a:xfrm>
+          <a:prstGeom prst="rect">
+            <a:avLst/>
+          </a:prstGeom>
+        </p:spPr>
+      </p:pic>
+    </p:spTree>
+  </p:cSld>
+  <p:clrMapOvr>
+    <a:masterClrMapping/>
+  </p:clrMapOvr>
+</p:sld>
+</file>
+
+<file path=ppt/slides/slide12.xml><?xml version="1.0" encoding="utf-8"?>
+<p:sld xmlns:a="http://schemas.openxmlformats.org/drawingml/2006/main" xmlns:r="http://schemas.openxmlformats.org/officeDocument/2006/relationships" xmlns:p="http://schemas.openxmlformats.org/presentationml/2006/main">
+  <p:cSld name="Slide 12">
+    <p:spTree>
+      <p:nvGrpSpPr>
+        <p:cNvPr id="1" name=""/>
+        <p:cNvGrpSpPr/>
+        <p:nvPr/>
+      </p:nvGrpSpPr>
+      <p:grpSpPr>
+        <a:xfrm>
+          <a:off x="0" y="0"/>
+          <a:ext cx="0" cy="0"/>
+          <a:chOff x="0" y="0"/>
+          <a:chExt cx="0" cy="0"/>
+        </a:xfrm>
+      </p:grpSpPr>
+      <p:pic>
+        <p:nvPicPr>
+          <p:cNvPr id="2" name="Image 0" descr="Slide 12">    </p:cNvPr>
           <p:cNvPicPr>
             <a:picLocks noChangeAspect="1"/>
           </p:cNvPicPr>

</xml_diff>

<commit_message>
Deck: question-led titles, PRIME architecture and semantic layer, demo as finale
Slide titles are the panel's six questions again, with no STAR labels. New
architecture and semantic-layer diagrams for question 2. About 9 minutes of
talk, then a 5-minute live demo before questions. Exports regenerated.

Co-Authored-By: Claude Opus 5.5 <noreply@anthropic.com>
</commit_message>
<xml_diff>
--- a/demos/calgary-transit/web/public/downloads/prime-case-study.pptx
+++ b/demos/calgary-transit/web/public/downloads/prime-case-study.pptx
@@ -513,8 +513,7 @@
           <a:p>
             <a:r>
               <a:rPr lang="en-US" dirty="0"/>
-              <a:t>• [Your story: one line on who you are.]
-• Then: 'I'll tell this as a STAR story. Each part answers your questions in order.'</a:t>
+              <a:t>• [Your story: one line on who you are.] Then: 'I'll answer your six questions in order, then show it live.'</a:t>
             </a:r>
             <a:endParaRPr lang="en-US" dirty="0"/>
           </a:p>
@@ -602,8 +601,8 @@
           <a:p>
             <a:r>
               <a:rPr lang="en-US" dirty="0"/>
-              <a:t>• Slow down here. This is the line to remember.
-• [Your story: the first time a team trusted an answer without double-checking it.]</a:t>
+              <a:t>• [Your story: swap in whatever you'd genuinely do differently.]
+• Transition: 'I can't show you StellarAlgo's data, so I rebuilt the same approach on the City's open data.'</a:t>
             </a:r>
             <a:endParaRPr lang="en-US" dirty="0"/>
           </a:p>
@@ -691,8 +690,12 @@
           <a:p>
             <a:r>
               <a:rPr lang="en-US" dirty="0"/>
-              <a:t>• [Your story: swap in whatever you'd genuinely do differently.]
-• Land the closing line slowly. It's the bridge to the role.</a:t>
+              <a:t>• LIVE (5 min). Open the site before the interview. If the internet fails, these screenshots carry it.
+• 1 · Approach page, lineage graph: 'Same medallion layers as PRIME: three City datasets, tested in dbt, run daily by Airflow.' (45 s)
+• 2 · Dashboard: read the ⓘ headline. Then the 311 chart: 'My first cut said complaints per trip were up 43%. Lost Property moved into 311 in 2021. I fixed it once, in the data, so every consumer gets it right. Like for like it's 12%.' (1.25 min)
+• 3 · Predict: Advertising and Communications (usually low), then Transit Pass Programs (usually high). 'Tested on 2025, a year it never saw, it catches more slow requests than the rule of thumb.' (1 min)
+• 4 · Ask: 'How has ridership recovered since the pandemic?' While it works: 'it writes SQL against the same gold tables.' Read the answer, glance at the chart, open 'Show how this was answered'. Payoff: 'Same number as the dashboard. That's PRIME's point.' (1.5 min)
+• Close: 'That's the work I'd bring to the City.' Then the last slide.</a:t>
             </a:r>
             <a:endParaRPr lang="en-US" dirty="0"/>
           </a:p>
@@ -868,7 +871,7 @@
           <a:p>
             <a:r>
               <a:rPr lang="en-US" dirty="0"/>
-              <a:t>• Thirty seconds. Don't read the boxes; just point at the letters.</a:t>
+              <a:t>• Fifteen seconds. Every slide title is one of their questions.</a:t>
             </a:r>
             <a:endParaRPr lang="en-US" dirty="0"/>
           </a:p>
@@ -956,8 +959,10 @@
           <a:p>
             <a:r>
               <a:rPr lang="en-US" dirty="0"/>
-              <a:t>• The multi-tenant design was right for the product, but it made internal reporting hard.
-• [Your story: one concrete moment when inconsistent numbers hurt: a client call, a leadership report.]</a:t>
+              <a:t>• Situation, then what people needed. Keep it to the business pain, not the tech.
+• My role: Director, Product Innovation &amp; Analytics. I owned PRIME's product management from planning to general availability.
+• [Your story: one concrete moment when inconsistent numbers hurt, and how you gathered what people needed.]
+• Say: 'Hold on to those five words. They're how I'll measure the result.'</a:t>
             </a:r>
             <a:endParaRPr lang="en-US" dirty="0"/>
           </a:p>
@@ -1045,8 +1050,9 @@
           <a:p>
             <a:r>
               <a:rPr lang="en-US" dirty="0"/>
-              <a:t>• [Your story: how you gathered requirements. Who you talked to, and what they asked for most.]
-• Say: 'These five became the checklist. I'll come back to each one in the results.'</a:t>
+              <a:t>• Walk it left to right once: three sources, transformed once, one semantic layer, every consumer.
+• Then the band: 'Governance isn't a separate project. It's built into every layer.'
+• Check the source names match what you'd say. Three source systems feed it.</a:t>
             </a:r>
             <a:endParaRPr lang="en-US" dirty="0"/>
           </a:p>
@@ -1134,8 +1140,8 @@
           <a:p>
             <a:r>
               <a:rPr lang="en-US" dirty="0"/>
-              <a:t>• Walk the flow left to right in one breath. The point: transform once, use everywhere.
-• My part: product owner. I worked with Data Engineering and Customer Success, with a small product pod.</a:t>
+              <a:t>• This is the technical heart. 'An AI that guesses the grain double counts. Each semantic model has one grain, so it can't.'
+• The example question and measures are illustrative. [Your story: a real question the CS bot answered.]</a:t>
             </a:r>
             <a:endParaRPr lang="en-US" dirty="0"/>
           </a:p>
@@ -1223,8 +1229,8 @@
           <a:p>
             <a:r>
               <a:rPr lang="en-US" dirty="0"/>
-              <a:t>• This is the 'show the product' moment. Trace the arrows once.
-• The example question is illustrative. [Your story: a real question the CS bot answered.]</a:t>
+              <a:t>• Check off the five needs from question 1. Don't read every label.
+• [Your story: an adoption or time-saved number. A real number beats 'no ticket'.]</a:t>
             </a:r>
             <a:endParaRPr lang="en-US" dirty="0"/>
           </a:p>
@@ -1312,8 +1318,8 @@
           <a:p>
             <a:r>
               <a:rPr lang="en-US" dirty="0"/>
-              <a:t>• Strategy first, tools last. The panel cares more about the why than the stack.
-• [Your story: the real build order, and what you'd sequence the same way again.]</a:t>
+              <a:t>• One breath across the strip. The panel cares more about the why than the stack.
+• [Your story: how you ran requirements, and the real build order.]</a:t>
             </a:r>
             <a:endParaRPr lang="en-US" dirty="0"/>
           </a:p>
@@ -1401,7 +1407,7 @@
           <a:p>
             <a:r>
               <a:rPr lang="en-US" dirty="0"/>
-              <a:t>• Spend most of the time on the People row. It's the one an analyst role at the City will relate to.
+              <a:t>• Spend most of the time on the People row. It's the one an analyst at the City will relate to.
 • [Your story: the conversation that got the data contract agreed. Who pushed back, and what changed their mind?]</a:t>
             </a:r>
             <a:endParaRPr lang="en-US" dirty="0"/>
@@ -1490,8 +1496,8 @@
           <a:p>
             <a:r>
               <a:rPr lang="en-US" dirty="0"/>
-              <a:t>• Tie each result back to the checklist from Task.
-• [Your story: an adoption or time-saved number. A real number beats 'no ticket'.]</a:t>
+              <a:t>• Slow down. This is the line to remember.
+• [Your story: the first time a team trusted an answer without double-checking it.]</a:t>
             </a:r>
             <a:endParaRPr lang="en-US" dirty="0"/>
           </a:p>

</xml_diff>